<commit_message>
Session 7: literature check before the contribution type
New order: project, literature check, contribution type, format, venue. The check is done in dialogue with the venue agent (no traffic-light verdict), and the gap it finds names the contribution type. Agent phases, search guide, brief and research workbook (steps 4 and 5 swapped, dates for steps 4-7) updated to match. Defence template: gap slide without the verdict. Briefing and agent steer away from artwork tracks.

Co-Authored-By: Claude Opus 5.5 <noreply@anthropic.com>
Claude-Session: https://claude.ai/code/session_01Bjee5xgzbTy5jsKWmCAe8B
</commit_message>
<xml_diff>
--- a/course/templates/idea_evaluation_defence.pptx
+++ b/course/templates/idea_evaluation_defence.pptx
@@ -688,7 +688,7 @@
               <a:rPr lang="en-US" dirty="0"/>
               <a:t>About 45 seconds. This slide comes from your literature check (my_work/literature_verification.md).
 Name the three works closest to yours — only works you have opened and checked yourself — and what each does not do.
-Then say the gap in one sentence, and your verdict: green (open), amber (partly done, so you narrowed the project) or red (done, so you changed it). If you changed or narrowed the project because of the check, say how.</a:t>
+Then say the gap in one sentence, and what you changed in your project because of the check — if anything.</a:t>
             </a:r>
             <a:endParaRPr lang="en-US" dirty="0"/>
           </a:p>
@@ -777,7 +777,7 @@
             <a:r>
               <a:rPr lang="en-US" dirty="0"/>
               <a:t>About 45 seconds. Sections 4, 5 and 7 of your idea evaluation.
-Say your contribution type and why. Then your contributions — each one names the problem, your method and what is gained, not just what you did.
+Say your contribution type, and how the gap points to it. Then your contributions — each one names the problem, your method and what is gained, not just what you did.
 Finish with the necessity test: take away the making, then the site. Both should break the project; say why.</a:t>
             </a:r>
             <a:endParaRPr lang="en-US" dirty="0"/>
@@ -2250,7 +2250,7 @@
                 <a:ea typeface="+mj-lt" pitchFamily="34" charset="-122"/>
                 <a:cs typeface="+mj-lt" pitchFamily="34" charset="-120"/>
               </a:rPr>
-              <a:t>The gap · verdict</a:t>
+              <a:t>The gap, and what changed</a:t>
             </a:r>
             <a:endParaRPr lang="en-US" sz="1800" dirty="0"/>
           </a:p>
@@ -2283,7 +2283,7 @@
               <a:buNone/>
             </a:pPr>
             <a:r>
-              <a:rPr lang="en-US" sz="1800" dirty="0">
+              <a:rPr lang="en-US" sz="1800" b="1" dirty="0">
                 <a:solidFill>
                   <a:schemeClr val="tx1"/>
                 </a:solidFill>
@@ -2303,12 +2303,12 @@
               <a:buNone/>
             </a:pPr>
             <a:r>
-              <a:rPr lang="en-US" sz="1800" b="1" dirty="0">
+              <a:rPr lang="en-US" sz="1800" dirty="0">
                 <a:solidFill>
                   <a:schemeClr val="tx1"/>
                 </a:solidFill>
               </a:rPr>
-              <a:t>[Verdict: green, amber or red]</a:t>
+              <a:t>[What you changed in your project because of the check]</a:t>
             </a:r>
             <a:endParaRPr lang="en-US" sz="1800" dirty="0"/>
           </a:p>

</xml_diff>